<commit_message>
Added acknowledgements, collaborator update slides.
</commit_message>
<xml_diff>
--- a/vis/reports/2026-02-19_projectUpdate_1_jmoran.pptx
+++ b/vis/reports/2026-02-19_projectUpdate_1_jmoran.pptx
@@ -5,7 +5,7 @@
     <p:sldMasterId id="2147483648" r:id="rId1"/>
   </p:sldMasterIdLst>
   <p:notesMasterIdLst>
-    <p:notesMasterId r:id="rId13"/>
+    <p:notesMasterId r:id="rId14"/>
   </p:notesMasterIdLst>
   <p:sldIdLst>
     <p:sldId id="256" r:id="rId2"/>
@@ -18,7 +18,8 @@
     <p:sldId id="264" r:id="rId9"/>
     <p:sldId id="265" r:id="rId10"/>
     <p:sldId id="266" r:id="rId11"/>
-    <p:sldId id="260" r:id="rId12"/>
+    <p:sldId id="267" r:id="rId12"/>
+    <p:sldId id="260" r:id="rId13"/>
   </p:sldIdLst>
   <p:sldSz cx="12192000" cy="6858000"/>
   <p:notesSz cx="6858000" cy="9144000"/>
@@ -4210,8 +4211,8 @@
         </p:nvSpPr>
         <p:spPr>
           <a:xfrm>
-            <a:off x="5198295" y="3239170"/>
-            <a:ext cx="6616011" cy="1277273"/>
+            <a:off x="5198295" y="3577498"/>
+            <a:ext cx="6616011" cy="1000274"/>
           </a:xfrm>
           <a:prstGeom prst="rect">
             <a:avLst/>
@@ -4329,7 +4330,7 @@
                 <a:spcPts val="600"/>
               </a:spcAft>
             </a:pPr>
-            <a:endParaRPr lang="en-US" sz="2400" b="1">
+            <a:endParaRPr lang="en-US" sz="2400" b="1" dirty="0">
               <a:solidFill>
                 <a:schemeClr val="bg1"/>
               </a:solidFill>
@@ -4350,14 +4351,14 @@
               </a:spcAft>
             </a:pPr>
             <a:r>
-              <a:rPr lang="en-US" sz="2400">
+              <a:rPr lang="en-US" sz="3000" dirty="0">
                 <a:solidFill>
                   <a:schemeClr val="bg1"/>
                 </a:solidFill>
-                <a:latin typeface="Courier New" panose="02070309020205020404" pitchFamily="49" charset="0"/>
+                <a:latin typeface="Georgia Pro" panose="02040502050405020303" pitchFamily="18" charset="0"/>
                 <a:cs typeface="Courier New" panose="02070309020205020404" pitchFamily="49" charset="0"/>
               </a:rPr>
-              <a:t>Bacterial anti-phage structural homology: update 1</a:t>
+              <a:t>IEI project: update 1</a:t>
             </a:r>
           </a:p>
         </p:txBody>
@@ -4566,7 +4567,7 @@
               </a:spcAft>
             </a:pPr>
             <a:r>
-              <a:rPr lang="en-US" sz="1400">
+              <a:rPr lang="en-US" sz="1400" dirty="0">
                 <a:solidFill>
                   <a:schemeClr val="bg1"/>
                 </a:solidFill>
@@ -4589,7 +4590,7 @@
               </a:spcAft>
             </a:pPr>
             <a:r>
-              <a:rPr lang="en-US" sz="1400">
+              <a:rPr lang="en-US" sz="1400" dirty="0">
                 <a:solidFill>
                   <a:schemeClr val="bg1"/>
                 </a:solidFill>
@@ -4612,7 +4613,7 @@
               </a:spcAft>
             </a:pPr>
             <a:r>
-              <a:rPr lang="en-US" sz="1400">
+              <a:rPr lang="en-US" sz="1400" dirty="0">
                 <a:solidFill>
                   <a:schemeClr val="bg1"/>
                 </a:solidFill>
@@ -5139,7 +5140,13 @@
   <p:cSld>
     <p:spTree>
       <p:nvGrpSpPr>
-        <p:cNvPr id="1" name=""/>
+        <p:cNvPr id="1" name="">
+          <a:extLst>
+            <a:ext uri="{FF2B5EF4-FFF2-40B4-BE49-F238E27FC236}">
+              <a16:creationId xmlns:a16="http://schemas.microsoft.com/office/drawing/2014/main" id="{43567E2B-84B7-B893-BD6B-69007979D069}"/>
+            </a:ext>
+          </a:extLst>
+        </p:cNvPr>
         <p:cNvGrpSpPr/>
         <p:nvPr/>
       </p:nvGrpSpPr>
@@ -5156,7 +5163,7 @@
           <p:cNvPr id="5" name="Rectangle: Rounded Corners 4">
             <a:extLst>
               <a:ext uri="{FF2B5EF4-FFF2-40B4-BE49-F238E27FC236}">
-                <a16:creationId xmlns:a16="http://schemas.microsoft.com/office/drawing/2014/main" id="{5A67C029-F809-4563-FEDC-0FE2666AD68F}"/>
+                <a16:creationId xmlns:a16="http://schemas.microsoft.com/office/drawing/2014/main" id="{FE506AB5-3FDE-99AB-1448-A292B80CF786}"/>
               </a:ext>
             </a:extLst>
           </p:cNvPr>
@@ -5304,7 +5311,7 @@
           <p:cNvPr id="6" name="TextBox 5">
             <a:extLst>
               <a:ext uri="{FF2B5EF4-FFF2-40B4-BE49-F238E27FC236}">
-                <a16:creationId xmlns:a16="http://schemas.microsoft.com/office/drawing/2014/main" id="{984295EC-59E3-A151-A598-185D8DFFA3C9}"/>
+                <a16:creationId xmlns:a16="http://schemas.microsoft.com/office/drawing/2014/main" id="{6583F51B-E4DA-C4CB-057C-D787C736EAC8}"/>
               </a:ext>
             </a:extLst>
           </p:cNvPr>
@@ -5328,13 +5335,13 @@
           <a:lstStyle/>
           <a:p>
             <a:r>
-              <a:rPr lang="en-US" sz="2400" b="1">
+              <a:rPr lang="en-US" sz="2400" b="1" dirty="0">
                 <a:solidFill>
                   <a:schemeClr val="bg1"/>
                 </a:solidFill>
                 <a:latin typeface="Georgia Pro" panose="02040502050405020303" pitchFamily="18" charset="0"/>
               </a:rPr>
-              <a:t>References</a:t>
+              <a:t>Acknowledgements</a:t>
             </a:r>
           </a:p>
         </p:txBody>
@@ -5344,7 +5351,7 @@
           <p:cNvPr id="7" name="Slide Number Placeholder 6">
             <a:extLst>
               <a:ext uri="{FF2B5EF4-FFF2-40B4-BE49-F238E27FC236}">
-                <a16:creationId xmlns:a16="http://schemas.microsoft.com/office/drawing/2014/main" id="{4AA63B0A-77DC-F94E-1603-6415DC566DB9}"/>
+                <a16:creationId xmlns:a16="http://schemas.microsoft.com/office/drawing/2014/main" id="{1ECF2186-8BC3-B8BD-FDBA-C2EF68B661F0}"/>
               </a:ext>
             </a:extLst>
           </p:cNvPr>
@@ -5364,6 +5371,464 @@
               <a:rPr lang="en-CA" smtClean="0"/>
               <a:pPr/>
               <a:t>11</a:t>
+            </a:fld>
+            <a:endParaRPr lang="en-CA" sz="1400"/>
+          </a:p>
+        </p:txBody>
+      </p:sp>
+      <p:sp>
+        <p:nvSpPr>
+          <p:cNvPr id="8" name="TextBox 7">
+            <a:extLst>
+              <a:ext uri="{FF2B5EF4-FFF2-40B4-BE49-F238E27FC236}">
+                <a16:creationId xmlns:a16="http://schemas.microsoft.com/office/drawing/2014/main" id="{DCFC6D50-D703-886B-2FD0-5E8A818B9311}"/>
+              </a:ext>
+            </a:extLst>
+          </p:cNvPr>
+          <p:cNvSpPr txBox="1"/>
+          <p:nvPr/>
+        </p:nvSpPr>
+        <p:spPr>
+          <a:xfrm>
+            <a:off x="845607" y="1725087"/>
+            <a:ext cx="4888217" cy="1277273"/>
+          </a:xfrm>
+          <a:prstGeom prst="rect">
+            <a:avLst/>
+          </a:prstGeom>
+          <a:noFill/>
+        </p:spPr>
+        <p:txBody>
+          <a:bodyPr wrap="square" rtlCol="0">
+            <a:spAutoFit/>
+          </a:bodyPr>
+          <a:lstStyle/>
+          <a:p>
+            <a:pPr lvl="0">
+              <a:spcAft>
+                <a:spcPts val="600"/>
+              </a:spcAft>
+            </a:pPr>
+            <a:r>
+              <a:rPr lang="en-US" dirty="0">
+                <a:latin typeface="Georgia Pro" panose="02040502050405020303" pitchFamily="18" charset="0"/>
+              </a:rPr>
+              <a:t>The Centre for Applied Genomics (TCAG)</a:t>
+            </a:r>
+          </a:p>
+          <a:p>
+            <a:pPr marL="285750" lvl="0" indent="-285750">
+              <a:buFont typeface="Arial" panose="020B0604020202020204" pitchFamily="34" charset="0"/>
+              <a:buChar char="•"/>
+            </a:pPr>
+            <a:r>
+              <a:rPr lang="en-US" dirty="0">
+                <a:latin typeface="Georgia Pro" panose="02040502050405020303" pitchFamily="18" charset="0"/>
+              </a:rPr>
+              <a:t>Vinicius Furlan</a:t>
+            </a:r>
+          </a:p>
+          <a:p>
+            <a:pPr marL="285750" lvl="0" indent="-285750">
+              <a:buFont typeface="Arial" panose="020B0604020202020204" pitchFamily="34" charset="0"/>
+              <a:buChar char="•"/>
+            </a:pPr>
+            <a:r>
+              <a:rPr lang="en-US" dirty="0">
+                <a:latin typeface="Georgia Pro" panose="02040502050405020303" pitchFamily="18" charset="0"/>
+              </a:rPr>
+              <a:t>Dr. Bank Engchuan</a:t>
+            </a:r>
+          </a:p>
+          <a:p>
+            <a:pPr marL="285750" lvl="0" indent="-285750">
+              <a:buFont typeface="Arial" panose="020B0604020202020204" pitchFamily="34" charset="0"/>
+              <a:buChar char="•"/>
+            </a:pPr>
+            <a:r>
+              <a:rPr lang="en-US" dirty="0">
+                <a:latin typeface="Georgia Pro" panose="02040502050405020303" pitchFamily="18" charset="0"/>
+              </a:rPr>
+              <a:t>Professor Stephen Scherer</a:t>
+            </a:r>
+          </a:p>
+        </p:txBody>
+      </p:sp>
+      <p:sp>
+        <p:nvSpPr>
+          <p:cNvPr id="2" name="TextBox 1">
+            <a:extLst>
+              <a:ext uri="{FF2B5EF4-FFF2-40B4-BE49-F238E27FC236}">
+                <a16:creationId xmlns:a16="http://schemas.microsoft.com/office/drawing/2014/main" id="{449A1820-1658-1584-3C9A-25ACF6BB0BAF}"/>
+              </a:ext>
+            </a:extLst>
+          </p:cNvPr>
+          <p:cNvSpPr txBox="1"/>
+          <p:nvPr/>
+        </p:nvSpPr>
+        <p:spPr>
+          <a:xfrm>
+            <a:off x="845608" y="3429000"/>
+            <a:ext cx="5146401" cy="1000274"/>
+          </a:xfrm>
+          <a:prstGeom prst="rect">
+            <a:avLst/>
+          </a:prstGeom>
+          <a:noFill/>
+        </p:spPr>
+        <p:txBody>
+          <a:bodyPr wrap="square" rtlCol="0">
+            <a:spAutoFit/>
+          </a:bodyPr>
+          <a:lstStyle/>
+          <a:p>
+            <a:pPr lvl="0">
+              <a:spcAft>
+                <a:spcPts val="600"/>
+              </a:spcAft>
+            </a:pPr>
+            <a:r>
+              <a:rPr lang="en-US" dirty="0">
+                <a:latin typeface="Georgia Pro" panose="02040502050405020303" pitchFamily="18" charset="0"/>
+              </a:rPr>
+              <a:t>The Centre for Computational Medicine (CCM)</a:t>
+            </a:r>
+          </a:p>
+          <a:p>
+            <a:pPr marL="285750" lvl="0" indent="-285750">
+              <a:buFont typeface="Arial" panose="020B0604020202020204" pitchFamily="34" charset="0"/>
+              <a:buChar char="•"/>
+            </a:pPr>
+            <a:r>
+              <a:rPr lang="en-US" dirty="0">
+                <a:latin typeface="Georgia Pro" panose="02040502050405020303" pitchFamily="18" charset="0"/>
+              </a:rPr>
+              <a:t>Anjali Vain</a:t>
+            </a:r>
+          </a:p>
+          <a:p>
+            <a:pPr marL="285750" lvl="0" indent="-285750">
+              <a:buFont typeface="Arial" panose="020B0604020202020204" pitchFamily="34" charset="0"/>
+              <a:buChar char="•"/>
+            </a:pPr>
+            <a:r>
+              <a:rPr lang="en-US" dirty="0">
+                <a:latin typeface="Georgia Pro" panose="02040502050405020303" pitchFamily="18" charset="0"/>
+              </a:rPr>
+              <a:t>Arteen Torabi-Marashi </a:t>
+            </a:r>
+          </a:p>
+        </p:txBody>
+      </p:sp>
+      <p:sp>
+        <p:nvSpPr>
+          <p:cNvPr id="3" name="TextBox 2">
+            <a:extLst>
+              <a:ext uri="{FF2B5EF4-FFF2-40B4-BE49-F238E27FC236}">
+                <a16:creationId xmlns:a16="http://schemas.microsoft.com/office/drawing/2014/main" id="{B859C9BD-6303-D18F-9C17-CBC1F9EB9620}"/>
+              </a:ext>
+            </a:extLst>
+          </p:cNvPr>
+          <p:cNvSpPr txBox="1"/>
+          <p:nvPr/>
+        </p:nvSpPr>
+        <p:spPr>
+          <a:xfrm>
+            <a:off x="845608" y="4855914"/>
+            <a:ext cx="5146401" cy="1000274"/>
+          </a:xfrm>
+          <a:prstGeom prst="rect">
+            <a:avLst/>
+          </a:prstGeom>
+          <a:noFill/>
+        </p:spPr>
+        <p:txBody>
+          <a:bodyPr wrap="square" rtlCol="0">
+            <a:spAutoFit/>
+          </a:bodyPr>
+          <a:lstStyle/>
+          <a:p>
+            <a:pPr lvl="0">
+              <a:spcAft>
+                <a:spcPts val="600"/>
+              </a:spcAft>
+            </a:pPr>
+            <a:r>
+              <a:rPr lang="en-US" dirty="0">
+                <a:latin typeface="Georgia Pro" panose="02040502050405020303" pitchFamily="18" charset="0"/>
+              </a:rPr>
+              <a:t>IEI project collaborators</a:t>
+            </a:r>
+          </a:p>
+          <a:p>
+            <a:pPr marL="285750" lvl="0" indent="-285750">
+              <a:buFont typeface="Arial" panose="020B0604020202020204" pitchFamily="34" charset="0"/>
+              <a:buChar char="•"/>
+            </a:pPr>
+            <a:r>
+              <a:rPr lang="en-US" dirty="0">
+                <a:latin typeface="Georgia Pro" panose="02040502050405020303" pitchFamily="18" charset="0"/>
+              </a:rPr>
+              <a:t>Dr. Chantel Trost</a:t>
+            </a:r>
+          </a:p>
+          <a:p>
+            <a:pPr marL="285750" lvl="0" indent="-285750">
+              <a:buFont typeface="Arial" panose="020B0604020202020204" pitchFamily="34" charset="0"/>
+              <a:buChar char="•"/>
+            </a:pPr>
+            <a:r>
+              <a:rPr lang="en-US" dirty="0">
+                <a:latin typeface="Georgia Pro" panose="02040502050405020303" pitchFamily="18" charset="0"/>
+              </a:rPr>
+              <a:t>Dr. Christian Marshall</a:t>
+            </a:r>
+          </a:p>
+        </p:txBody>
+      </p:sp>
+    </p:spTree>
+    <p:extLst>
+      <p:ext uri="{BB962C8B-B14F-4D97-AF65-F5344CB8AC3E}">
+        <p14:creationId xmlns:p14="http://schemas.microsoft.com/office/powerpoint/2010/main" val="1395744058"/>
+      </p:ext>
+    </p:extLst>
+  </p:cSld>
+  <p:clrMapOvr>
+    <a:masterClrMapping/>
+  </p:clrMapOvr>
+</p:sld>
+</file>
+
+<file path=ppt/slides/slide12.xml><?xml version="1.0" encoding="utf-8"?>
+<p:sld xmlns:a="http://schemas.openxmlformats.org/drawingml/2006/main" xmlns:r="http://schemas.openxmlformats.org/officeDocument/2006/relationships" xmlns:p="http://schemas.openxmlformats.org/presentationml/2006/main">
+  <p:cSld>
+    <p:spTree>
+      <p:nvGrpSpPr>
+        <p:cNvPr id="1" name=""/>
+        <p:cNvGrpSpPr/>
+        <p:nvPr/>
+      </p:nvGrpSpPr>
+      <p:grpSpPr>
+        <a:xfrm>
+          <a:off x="0" y="0"/>
+          <a:ext cx="0" cy="0"/>
+          <a:chOff x="0" y="0"/>
+          <a:chExt cx="0" cy="0"/>
+        </a:xfrm>
+      </p:grpSpPr>
+      <p:sp>
+        <p:nvSpPr>
+          <p:cNvPr id="5" name="Rectangle: Rounded Corners 4">
+            <a:extLst>
+              <a:ext uri="{FF2B5EF4-FFF2-40B4-BE49-F238E27FC236}">
+                <a16:creationId xmlns:a16="http://schemas.microsoft.com/office/drawing/2014/main" id="{5A67C029-F809-4563-FEDC-0FE2666AD68F}"/>
+              </a:ext>
+            </a:extLst>
+          </p:cNvPr>
+          <p:cNvSpPr/>
+          <p:nvPr/>
+        </p:nvSpPr>
+        <p:spPr>
+          <a:xfrm>
+            <a:off x="845609" y="649223"/>
+            <a:ext cx="4704799" cy="649225"/>
+          </a:xfrm>
+          <a:prstGeom prst="roundRect">
+            <a:avLst/>
+          </a:prstGeom>
+          <a:solidFill>
+            <a:srgbClr val="0162B3"/>
+          </a:solidFill>
+          <a:ln>
+            <a:solidFill>
+              <a:srgbClr val="0162B3"/>
+            </a:solidFill>
+          </a:ln>
+        </p:spPr>
+        <p:style>
+          <a:lnRef idx="2">
+            <a:schemeClr val="accent1">
+              <a:shade val="50000"/>
+            </a:schemeClr>
+          </a:lnRef>
+          <a:fillRef idx="1">
+            <a:schemeClr val="accent1"/>
+          </a:fillRef>
+          <a:effectRef idx="0">
+            <a:schemeClr val="accent1"/>
+          </a:effectRef>
+          <a:fontRef idx="minor">
+            <a:schemeClr val="lt1"/>
+          </a:fontRef>
+        </p:style>
+        <p:txBody>
+          <a:bodyPr rtlCol="0" anchor="ctr"/>
+          <a:lstStyle>
+            <a:defPPr>
+              <a:defRPr lang="en-US"/>
+            </a:defPPr>
+            <a:lvl1pPr marL="0" algn="l" defTabSz="914400" rtl="0" eaLnBrk="1" latinLnBrk="0" hangingPunct="1">
+              <a:defRPr sz="1800" kern="1200">
+                <a:solidFill>
+                  <a:schemeClr val="lt1"/>
+                </a:solidFill>
+                <a:latin typeface="+mn-lt"/>
+                <a:ea typeface="+mn-ea"/>
+                <a:cs typeface="+mn-cs"/>
+              </a:defRPr>
+            </a:lvl1pPr>
+            <a:lvl2pPr marL="457200" algn="l" defTabSz="914400" rtl="0" eaLnBrk="1" latinLnBrk="0" hangingPunct="1">
+              <a:defRPr sz="1800" kern="1200">
+                <a:solidFill>
+                  <a:schemeClr val="lt1"/>
+                </a:solidFill>
+                <a:latin typeface="+mn-lt"/>
+                <a:ea typeface="+mn-ea"/>
+                <a:cs typeface="+mn-cs"/>
+              </a:defRPr>
+            </a:lvl2pPr>
+            <a:lvl3pPr marL="914400" algn="l" defTabSz="914400" rtl="0" eaLnBrk="1" latinLnBrk="0" hangingPunct="1">
+              <a:defRPr sz="1800" kern="1200">
+                <a:solidFill>
+                  <a:schemeClr val="lt1"/>
+                </a:solidFill>
+                <a:latin typeface="+mn-lt"/>
+                <a:ea typeface="+mn-ea"/>
+                <a:cs typeface="+mn-cs"/>
+              </a:defRPr>
+            </a:lvl3pPr>
+            <a:lvl4pPr marL="1371600" algn="l" defTabSz="914400" rtl="0" eaLnBrk="1" latinLnBrk="0" hangingPunct="1">
+              <a:defRPr sz="1800" kern="1200">
+                <a:solidFill>
+                  <a:schemeClr val="lt1"/>
+                </a:solidFill>
+                <a:latin typeface="+mn-lt"/>
+                <a:ea typeface="+mn-ea"/>
+                <a:cs typeface="+mn-cs"/>
+              </a:defRPr>
+            </a:lvl4pPr>
+            <a:lvl5pPr marL="1828800" algn="l" defTabSz="914400" rtl="0" eaLnBrk="1" latinLnBrk="0" hangingPunct="1">
+              <a:defRPr sz="1800" kern="1200">
+                <a:solidFill>
+                  <a:schemeClr val="lt1"/>
+                </a:solidFill>
+                <a:latin typeface="+mn-lt"/>
+                <a:ea typeface="+mn-ea"/>
+                <a:cs typeface="+mn-cs"/>
+              </a:defRPr>
+            </a:lvl5pPr>
+            <a:lvl6pPr marL="2286000" algn="l" defTabSz="914400" rtl="0" eaLnBrk="1" latinLnBrk="0" hangingPunct="1">
+              <a:defRPr sz="1800" kern="1200">
+                <a:solidFill>
+                  <a:schemeClr val="lt1"/>
+                </a:solidFill>
+                <a:latin typeface="+mn-lt"/>
+                <a:ea typeface="+mn-ea"/>
+                <a:cs typeface="+mn-cs"/>
+              </a:defRPr>
+            </a:lvl6pPr>
+            <a:lvl7pPr marL="2743200" algn="l" defTabSz="914400" rtl="0" eaLnBrk="1" latinLnBrk="0" hangingPunct="1">
+              <a:defRPr sz="1800" kern="1200">
+                <a:solidFill>
+                  <a:schemeClr val="lt1"/>
+                </a:solidFill>
+                <a:latin typeface="+mn-lt"/>
+                <a:ea typeface="+mn-ea"/>
+                <a:cs typeface="+mn-cs"/>
+              </a:defRPr>
+            </a:lvl7pPr>
+            <a:lvl8pPr marL="3200400" algn="l" defTabSz="914400" rtl="0" eaLnBrk="1" latinLnBrk="0" hangingPunct="1">
+              <a:defRPr sz="1800" kern="1200">
+                <a:solidFill>
+                  <a:schemeClr val="lt1"/>
+                </a:solidFill>
+                <a:latin typeface="+mn-lt"/>
+                <a:ea typeface="+mn-ea"/>
+                <a:cs typeface="+mn-cs"/>
+              </a:defRPr>
+            </a:lvl8pPr>
+            <a:lvl9pPr marL="3657600" algn="l" defTabSz="914400" rtl="0" eaLnBrk="1" latinLnBrk="0" hangingPunct="1">
+              <a:defRPr sz="1800" kern="1200">
+                <a:solidFill>
+                  <a:schemeClr val="lt1"/>
+                </a:solidFill>
+                <a:latin typeface="+mn-lt"/>
+                <a:ea typeface="+mn-ea"/>
+                <a:cs typeface="+mn-cs"/>
+              </a:defRPr>
+            </a:lvl9pPr>
+          </a:lstStyle>
+          <a:p>
+            <a:pPr algn="ctr"/>
+            <a:endParaRPr lang="en-CA"/>
+          </a:p>
+        </p:txBody>
+      </p:sp>
+      <p:sp>
+        <p:nvSpPr>
+          <p:cNvPr id="6" name="TextBox 5">
+            <a:extLst>
+              <a:ext uri="{FF2B5EF4-FFF2-40B4-BE49-F238E27FC236}">
+                <a16:creationId xmlns:a16="http://schemas.microsoft.com/office/drawing/2014/main" id="{984295EC-59E3-A151-A598-185D8DFFA3C9}"/>
+              </a:ext>
+            </a:extLst>
+          </p:cNvPr>
+          <p:cNvSpPr txBox="1"/>
+          <p:nvPr/>
+        </p:nvSpPr>
+        <p:spPr>
+          <a:xfrm>
+            <a:off x="987552" y="761737"/>
+            <a:ext cx="3538728" cy="461665"/>
+          </a:xfrm>
+          <a:prstGeom prst="rect">
+            <a:avLst/>
+          </a:prstGeom>
+          <a:noFill/>
+        </p:spPr>
+        <p:txBody>
+          <a:bodyPr wrap="square" rtlCol="0">
+            <a:spAutoFit/>
+          </a:bodyPr>
+          <a:lstStyle/>
+          <a:p>
+            <a:r>
+              <a:rPr lang="en-US" sz="2400" b="1">
+                <a:solidFill>
+                  <a:schemeClr val="bg1"/>
+                </a:solidFill>
+                <a:latin typeface="Georgia Pro" panose="02040502050405020303" pitchFamily="18" charset="0"/>
+              </a:rPr>
+              <a:t>References</a:t>
+            </a:r>
+          </a:p>
+        </p:txBody>
+      </p:sp>
+      <p:sp>
+        <p:nvSpPr>
+          <p:cNvPr id="7" name="Slide Number Placeholder 6">
+            <a:extLst>
+              <a:ext uri="{FF2B5EF4-FFF2-40B4-BE49-F238E27FC236}">
+                <a16:creationId xmlns:a16="http://schemas.microsoft.com/office/drawing/2014/main" id="{4AA63B0A-77DC-F94E-1603-6415DC566DB9}"/>
+              </a:ext>
+            </a:extLst>
+          </p:cNvPr>
+          <p:cNvSpPr>
+            <a:spLocks noGrp="1"/>
+          </p:cNvSpPr>
+          <p:nvPr>
+            <p:ph type="sldNum" sz="quarter" idx="12"/>
+          </p:nvPr>
+        </p:nvSpPr>
+        <p:spPr/>
+        <p:txBody>
+          <a:bodyPr/>
+          <a:lstStyle/>
+          <a:p>
+            <a:fld id="{3899FC77-40C7-4C49-9A19-86BDE9B75E8A}" type="slidenum">
+              <a:rPr lang="en-CA" smtClean="0"/>
+              <a:pPr/>
+              <a:t>12</a:t>
             </a:fld>
             <a:endParaRPr lang="en-CA" sz="1400"/>
           </a:p>
@@ -9752,37 +10217,16 @@
                 <a:latin typeface="Courier New" panose="02070309020205020404" pitchFamily="49" charset="0"/>
                 <a:cs typeface="Courier New" panose="02070309020205020404" pitchFamily="49" charset="0"/>
               </a:rPr>
-              <a:t>DefenseFinder </a:t>
-            </a:r>
-            <a:r>
-              <a:rPr lang="en-US" sz="1400" dirty="0" err="1">
-                <a:latin typeface="Courier New" panose="02070309020205020404" pitchFamily="49" charset="0"/>
-                <a:cs typeface="Courier New" panose="02070309020205020404" pitchFamily="49" charset="0"/>
-              </a:rPr>
-              <a:t>cluster_id</a:t>
-            </a:r>
+              <a:t>DefenseFinder cluster_id ==</a:t>
+            </a:r>
+          </a:p>
+          <a:p>
             <a:r>
               <a:rPr lang="en-US" sz="1400" dirty="0">
                 <a:latin typeface="Courier New" panose="02070309020205020404" pitchFamily="49" charset="0"/>
                 <a:cs typeface="Courier New" panose="02070309020205020404" pitchFamily="49" charset="0"/>
               </a:rPr>
-              <a:t> ==</a:t>
-            </a:r>
-          </a:p>
-          <a:p>
-            <a:r>
-              <a:rPr lang="en-US" sz="1400" dirty="0">
-                <a:latin typeface="Courier New" panose="02070309020205020404" pitchFamily="49" charset="0"/>
-                <a:cs typeface="Courier New" panose="02070309020205020404" pitchFamily="49" charset="0"/>
-              </a:rPr>
-              <a:t>H. sapiens </a:t>
-            </a:r>
-            <a:r>
-              <a:rPr lang="en-US" sz="1400" dirty="0" err="1">
-                <a:latin typeface="Courier New" panose="02070309020205020404" pitchFamily="49" charset="0"/>
-                <a:cs typeface="Courier New" panose="02070309020205020404" pitchFamily="49" charset="0"/>
-              </a:rPr>
-              <a:t>cluster_id</a:t>
+              <a:t>H. sapiens cluster_id</a:t>
             </a:r>
             <a:endParaRPr lang="en-CA" sz="1400" dirty="0">
               <a:latin typeface="Courier New" panose="02070309020205020404" pitchFamily="49" charset="0"/>

</xml_diff>

<commit_message>
Added notes from progress update meeting.
</commit_message>
<xml_diff>
--- a/vis/reports/2026-02-19_projectUpdate_1_jmoran.pptx
+++ b/vis/reports/2026-02-19_projectUpdate_1_jmoran.pptx
@@ -5979,7 +5979,7 @@
         <p:spPr>
           <a:xfrm>
             <a:off x="845609" y="1874728"/>
-            <a:ext cx="9272016" cy="2769989"/>
+            <a:ext cx="9272016" cy="3123932"/>
           </a:xfrm>
           <a:prstGeom prst="rect">
             <a:avLst/>
@@ -6037,12 +6037,20 @@
             </a:r>
           </a:p>
           <a:p>
-            <a:pPr marL="342900" lvl="0" indent="-342900">
+            <a:pPr lvl="0">
               <a:spcAft>
                 <a:spcPts val="600"/>
               </a:spcAft>
-              <a:buFont typeface="+mj-lt"/>
-              <a:buAutoNum type="arabicPeriod"/>
+            </a:pPr>
+            <a:endParaRPr lang="en-US" dirty="0">
+              <a:latin typeface="Georgia Pro" panose="02040502050405020303" pitchFamily="18" charset="0"/>
+            </a:endParaRPr>
+          </a:p>
+          <a:p>
+            <a:pPr lvl="0">
+              <a:spcAft>
+                <a:spcPts val="600"/>
+              </a:spcAft>
             </a:pPr>
             <a:endParaRPr lang="en-US" dirty="0">
               <a:latin typeface="Georgia Pro" panose="02040502050405020303" pitchFamily="18" charset="0"/>
@@ -7089,13 +7097,13 @@
                   <a:rPr lang="en-US" sz="1600" b="1" dirty="0">
                     <a:latin typeface="Georgia Pro" panose="02040502050405020303" pitchFamily="18" charset="0"/>
                   </a:rPr>
-                  <a:t>Foldseek</a:t>
+                  <a:t>Foldseek cluster</a:t>
                 </a:r>
                 <a:r>
                   <a:rPr lang="en-US" sz="1600" dirty="0">
                     <a:latin typeface="Georgia Pro" panose="02040502050405020303" pitchFamily="18" charset="0"/>
                   </a:rPr>
-                  <a:t>, a protein structure search algorithm, depends on </a:t>
+                  <a:t> depends on </a:t>
                 </a:r>
                 <a:r>
                   <a:rPr lang="en-US" sz="1600" b="1" dirty="0">
@@ -11176,13 +11184,20 @@
           <a:lstStyle/>
           <a:p>
             <a:r>
-              <a:rPr lang="en-US" sz="1400">
+              <a:rPr lang="en-US" sz="1400" dirty="0" err="1">
                 <a:latin typeface="Courier New" panose="02070309020205020404" pitchFamily="49" charset="0"/>
                 <a:cs typeface="Courier New" panose="02070309020205020404" pitchFamily="49" charset="0"/>
               </a:rPr>
-              <a:t>Protein_length_difference ≤ 0.05 </a:t>
-            </a:r>
-            <a:endParaRPr lang="en-CA" sz="1400">
+              <a:t>Protein_length_difference</a:t>
+            </a:r>
+            <a:r>
+              <a:rPr lang="en-US" sz="1400" dirty="0">
+                <a:latin typeface="Courier New" panose="02070309020205020404" pitchFamily="49" charset="0"/>
+                <a:cs typeface="Courier New" panose="02070309020205020404" pitchFamily="49" charset="0"/>
+              </a:rPr>
+              <a:t> ≤ 0.05 </a:t>
+            </a:r>
+            <a:endParaRPr lang="en-CA" sz="1400" dirty="0">
               <a:latin typeface="Courier New" panose="02070309020205020404" pitchFamily="49" charset="0"/>
               <a:cs typeface="Courier New" panose="02070309020205020404" pitchFamily="49" charset="0"/>
             </a:endParaRPr>
@@ -11240,43 +11255,6 @@
           </a:p>
         </p:txBody>
       </p:sp>
-      <p:pic>
-        <p:nvPicPr>
-          <p:cNvPr id="17" name="Graphic 16">
-            <a:extLst>
-              <a:ext uri="{FF2B5EF4-FFF2-40B4-BE49-F238E27FC236}">
-                <a16:creationId xmlns:a16="http://schemas.microsoft.com/office/drawing/2014/main" id="{4ECE2338-E962-3219-2BEC-675AA0198A06}"/>
-              </a:ext>
-            </a:extLst>
-          </p:cNvPr>
-          <p:cNvPicPr>
-            <a:picLocks noChangeAspect="1"/>
-          </p:cNvPicPr>
-          <p:nvPr/>
-        </p:nvPicPr>
-        <p:blipFill>
-          <a:blip r:embed="rId2">
-            <a:extLst>
-              <a:ext uri="{96DAC541-7B7A-43D3-8B79-37D633B846F1}">
-                <asvg:svgBlip xmlns:asvg="http://schemas.microsoft.com/office/drawing/2016/SVG/main" r:embed="rId3"/>
-              </a:ext>
-            </a:extLst>
-          </a:blip>
-          <a:srcRect l="5848" t="11704" r="7567"/>
-          <a:stretch>
-            <a:fillRect/>
-          </a:stretch>
-        </p:blipFill>
-        <p:spPr>
-          <a:xfrm>
-            <a:off x="7134078" y="3630656"/>
-            <a:ext cx="4901914" cy="2999231"/>
-          </a:xfrm>
-          <a:prstGeom prst="rect">
-            <a:avLst/>
-          </a:prstGeom>
-        </p:spPr>
-      </p:pic>
       <p:sp>
         <p:nvSpPr>
           <p:cNvPr id="18" name="Slide Number Placeholder 17">
@@ -11395,6 +11373,43 @@
           </a:p>
         </p:txBody>
       </p:sp>
+      <p:pic>
+        <p:nvPicPr>
+          <p:cNvPr id="17" name="Graphic 16">
+            <a:extLst>
+              <a:ext uri="{FF2B5EF4-FFF2-40B4-BE49-F238E27FC236}">
+                <a16:creationId xmlns:a16="http://schemas.microsoft.com/office/drawing/2014/main" id="{4ECE2338-E962-3219-2BEC-675AA0198A06}"/>
+              </a:ext>
+            </a:extLst>
+          </p:cNvPr>
+          <p:cNvPicPr>
+            <a:picLocks noChangeAspect="1"/>
+          </p:cNvPicPr>
+          <p:nvPr/>
+        </p:nvPicPr>
+        <p:blipFill>
+          <a:blip r:embed="rId2">
+            <a:extLst>
+              <a:ext uri="{96DAC541-7B7A-43D3-8B79-37D633B846F1}">
+                <asvg:svgBlip xmlns:asvg="http://schemas.microsoft.com/office/drawing/2016/SVG/main" r:embed="rId3"/>
+              </a:ext>
+            </a:extLst>
+          </a:blip>
+          <a:srcRect l="5848" t="11704" r="7567"/>
+          <a:stretch>
+            <a:fillRect/>
+          </a:stretch>
+        </p:blipFill>
+        <p:spPr>
+          <a:xfrm>
+            <a:off x="6952923" y="3358681"/>
+            <a:ext cx="4901914" cy="2999231"/>
+          </a:xfrm>
+          <a:prstGeom prst="rect">
+            <a:avLst/>
+          </a:prstGeom>
+        </p:spPr>
+      </p:pic>
     </p:spTree>
     <p:extLst>
       <p:ext uri="{BB962C8B-B14F-4D97-AF65-F5344CB8AC3E}">
@@ -17634,7 +17649,7 @@
         </p:nvSpPr>
         <p:spPr>
           <a:xfrm>
-            <a:off x="709871" y="3310854"/>
+            <a:off x="709871" y="3388488"/>
             <a:ext cx="4324868" cy="523220"/>
           </a:xfrm>
           <a:prstGeom prst="rect">

</xml_diff>